<commit_message>
Correct the certificate validity note and add demo cues to the theory IA files
</commit_message>
<xml_diff>
--- a/docs/Traefik-Theory-IA-Presentation.pptx
+++ b/docs/Traefik-Theory-IA-Presentation.pptx
@@ -599,27 +599,85 @@
           <a:lstStyle/>
           <a:p>
             <a:r>
-              <a:t>[About 1:45. On screen: Slide 10 for ten seconds, then switch to the terminal and run the Demo 2 commands. Show the dashboard certificate page, then switch back to the slide.]</a:t>
-            </a:r>
-          </a:p>
-          <a:p>
-            <a:r>
-              <a:t>I can't use Let's Encrypt from a laptop, so I used Pebble, which is Let's Encrypt's own test server. It speaks the same protocol, so Traefik can't tell the difference. I start Pebble, its challenge server, and Traefik.</a:t>
-            </a:r>
-          </a:p>
-          <a:p>
-            <a:r>
-              <a:t>Then I start an app whose router asks for the resolver. Look at Traefik's log: it registers, obtains a certificate, the validations succeed, and the server responds with a certificate. I didn't run any certificate command.</a:t>
-            </a:r>
-          </a:p>
-          <a:p>
-            <a:r>
-              <a:t>Now I check from the client side. The certificate is issued by Pebble's intermediate CA, it works over TLS 1.3, and it verifies when I trust Pebble's root. Without that root, verification fails, as it should. The dashboard shows the router with its resolver, and the certificate.</a:t>
-            </a:r>
-          </a:p>
-          <a:p>
-            <a:r>
-              <a:t>One limit: this used a test authority, not Let's Encrypt itself.</a:t>
+              <a:t>[About 1:45. Say the first line on the slide. Then switch to the terminal and run ./demo.sh 2. Say each numbered line as you press Enter on that step. Switch back to the slide for the last line.]</a:t>
+            </a:r>
+          </a:p>
+          <a:p/>
+          <a:p>
+            <a:r>
+              <a:t>ON THE SLIDE</a:t>
+            </a:r>
+          </a:p>
+          <a:p>
+            <a:r>
+              <a:t>The second demo is automatic HTTPS. I can't use Let's Encrypt from a laptop, so I use Pebble, Let's Encrypt's own test server. It speaks the same protocol, so Traefik can't tell the difference.</a:t>
+            </a:r>
+          </a:p>
+          <a:p/>
+          <a:p>
+            <a:r>
+              <a:t>IN THE TERMINAL (./demo.sh 2)</a:t>
+            </a:r>
+          </a:p>
+          <a:p>
+            <a:r>
+              <a:t>1. [docker compose up -d] I start Pebble, its challenge server, and Traefik.</a:t>
+            </a:r>
+          </a:p>
+          <a:p>
+            <a:r>
+              <a:t>2. [start the app] Then I start an app whose router asks for a certificate.</a:t>
+            </a:r>
+          </a:p>
+          <a:p>
+            <a:r>
+              <a:t>3. [Traefik's log] Look at Traefik's log: it registers, obtains a certificate, the validations succeed, and the server responds with a certificate. I didn't run any certificate command.</a:t>
+            </a:r>
+          </a:p>
+          <a:p>
+            <a:r>
+              <a:t>4. [fetch the root] To check from the client side, I fetch Pebble's root certificate and trust only that.</a:t>
+            </a:r>
+          </a:p>
+          <a:p>
+            <a:r>
+              <a:t>5. [curl over HTTPS] The app answers over HTTPS.</a:t>
+            </a:r>
+          </a:p>
+          <a:p>
+            <a:r>
+              <a:t>6. [issuer and dates] The certificate was issued by Pebble's intermediate CA.</a:t>
+            </a:r>
+          </a:p>
+          <a:p>
+            <a:r>
+              <a:t>7. [verify] And the chain verifies.</a:t>
+            </a:r>
+          </a:p>
+          <a:p>
+            <a:r>
+              <a:t>8. [without the root] Without that root, verification fails, as it should.</a:t>
+            </a:r>
+          </a:p>
+          <a:p>
+            <a:r>
+              <a:t>9. [open the dashboard] The dashboard shows the router with its resolver, and the certificate.</a:t>
+            </a:r>
+          </a:p>
+          <a:p>
+            <a:r>
+              <a:t>10. [clean up] One limit: this used a test authority, not Let's Encrypt itself.</a:t>
+            </a:r>
+          </a:p>
+          <a:p/>
+          <a:p>
+            <a:r>
+              <a:t>BACK ON THE SLIDE</a:t>
+            </a:r>
+          </a:p>
+          <a:p>
+            <a:r>
+              <a:t>That is the second feature: Traefik got and installed a certificate by itself.</a:t>
             </a:r>
           </a:p>
         </p:txBody>
@@ -1504,27 +1562,100 @@
           <a:lstStyle/>
           <a:p>
             <a:r>
-              <a:t>[About 1:45. On screen: Slide 7 for ten seconds, then switch to the terminal and run the Demo 1 commands. Switch back to the slide at the end.]</a:t>
-            </a:r>
-          </a:p>
-          <a:p>
-            <a:r>
-              <a:t>I start Traefik with no apps. Its API lists only its own two routers, and a request for my app's hostname gets a 404.</a:t>
-            </a:r>
-          </a:p>
-          <a:p>
-            <a:r>
-              <a:t>Now I start the first app. Traefik isn't touched. The same request returns 200, and you can see the header my middleware added.</a:t>
-            </a:r>
-          </a:p>
-          <a:p>
-            <a:r>
-              <a:t>I add a second app with its own hostname, and that works too. Now I scale the first app to three copies. Six requests in a row, and they rotate across all three containers. Here they are in the dashboard.</a:t>
-            </a:r>
-          </a:p>
-          <a:p>
-            <a:r>
-              <a:t>Finally I stop the second app, and its hostname goes back to 404. Traefik started once at the beginning and was never restarted.</a:t>
+              <a:t>[About 1:45. Say the first line on the slide. Then switch to the terminal and run ./demo.sh 1. Say each numbered line as you press Enter on that step. Switch back to the slide for the last line.]</a:t>
+            </a:r>
+          </a:p>
+          <a:p/>
+          <a:p>
+            <a:r>
+              <a:t>ON THE SLIDE</a:t>
+            </a:r>
+          </a:p>
+          <a:p>
+            <a:r>
+              <a:t>The first demo is service discovery. I start Traefik with no apps, add apps while it runs, and watch whether the routes follow.</a:t>
+            </a:r>
+          </a:p>
+          <a:p/>
+          <a:p>
+            <a:r>
+              <a:t>IN THE TERMINAL (./demo.sh 1)</a:t>
+            </a:r>
+          </a:p>
+          <a:p>
+            <a:r>
+              <a:t>1. [docker compose up -d] I start Traefik with no apps.</a:t>
+            </a:r>
+          </a:p>
+          <a:p>
+            <a:r>
+              <a:t>2. [curl the routers] Its API lists only its own two routers.</a:t>
+            </a:r>
+          </a:p>
+          <a:p>
+            <a:r>
+              <a:t>3. [curl, 404] A request for my app's hostname gets a 404.</a:t>
+            </a:r>
+          </a:p>
+          <a:p>
+            <a:r>
+              <a:t>4. [start whoami] Now I start the first app. Traefik isn't touched.</a:t>
+            </a:r>
+          </a:p>
+          <a:p>
+            <a:r>
+              <a:t>5. [curl -i, 200] The same request returns 200, and you can see the header my middleware added.</a:t>
+            </a:r>
+          </a:p>
+          <a:p>
+            <a:r>
+              <a:t>6. [start hello] I add a second app with its own hostname,</a:t>
+            </a:r>
+          </a:p>
+          <a:p>
+            <a:r>
+              <a:t>7. [curl hello] and that works too.</a:t>
+            </a:r>
+          </a:p>
+          <a:p>
+            <a:r>
+              <a:t>8. [scale to 3] Now I scale the first app to three copies.</a:t>
+            </a:r>
+          </a:p>
+          <a:p>
+            <a:r>
+              <a:t>9. [loop of six requests] Six requests in a row, and they rotate across all three containers.</a:t>
+            </a:r>
+          </a:p>
+          <a:p>
+            <a:r>
+              <a:t>10. [open the dashboard] Here they are in the dashboard.</a:t>
+            </a:r>
+          </a:p>
+          <a:p>
+            <a:r>
+              <a:t>11. [stop hello] Finally I stop the second app,</a:t>
+            </a:r>
+          </a:p>
+          <a:p>
+            <a:r>
+              <a:t>12. [curl, 404] and its hostname goes back to 404.</a:t>
+            </a:r>
+          </a:p>
+          <a:p>
+            <a:r>
+              <a:t>13. [clean up] Traefik started once at the beginning and was never restarted.</a:t>
+            </a:r>
+          </a:p>
+          <a:p/>
+          <a:p>
+            <a:r>
+              <a:t>BACK ON THE SLIDE</a:t>
+            </a:r>
+          </a:p>
+          <a:p>
+            <a:r>
+              <a:t>That is the first feature: no file edited and no restart.</a:t>
             </a:r>
           </a:p>
         </p:txBody>
@@ -14445,7 +14576,7 @@
               </a:spcAft>
             </a:pPr>
             <a:r>
-              <a:rPr sz="2300" b="1" i="0">
+              <a:rPr sz="2100" b="1" i="0">
                 <a:solidFill>
                   <a:srgbClr val="10263F"/>
                 </a:solidFill>
@@ -14629,7 +14760,7 @@
               </a:spcAft>
             </a:pPr>
             <a:r>
-              <a:rPr sz="2300" b="1" i="0">
+              <a:rPr sz="2100" b="1" i="0">
                 <a:solidFill>
                   <a:srgbClr val="10263F"/>
                 </a:solidFill>

</xml_diff>